<commit_message>
renumber notebooks for better organization
</commit_message>
<xml_diff>
--- a/Lectures/Day1_0Introductions.pptx
+++ b/Lectures/Day1_0Introductions.pptx
@@ -430,7 +430,7 @@
           <a:p>
             <a:fld id="{6287D022-4AB8-4563-B2ED-986503007F94}" type="datetimeFigureOut">
               <a:rPr lang="en-US" smtClean="0"/>
-              <a:t>3/19/2026</a:t>
+              <a:t>6/24/2026</a:t>
             </a:fld>
             <a:endParaRPr lang="en-US"/>
           </a:p>
@@ -628,7 +628,7 @@
           <a:p>
             <a:fld id="{6287D022-4AB8-4563-B2ED-986503007F94}" type="datetimeFigureOut">
               <a:rPr lang="en-US" smtClean="0"/>
-              <a:t>3/19/2026</a:t>
+              <a:t>6/24/2026</a:t>
             </a:fld>
             <a:endParaRPr lang="en-US"/>
           </a:p>
@@ -836,7 +836,7 @@
           <a:p>
             <a:fld id="{6287D022-4AB8-4563-B2ED-986503007F94}" type="datetimeFigureOut">
               <a:rPr lang="en-US" smtClean="0"/>
-              <a:t>3/19/2026</a:t>
+              <a:t>6/24/2026</a:t>
             </a:fld>
             <a:endParaRPr lang="en-US"/>
           </a:p>
@@ -1034,7 +1034,7 @@
           <a:p>
             <a:fld id="{6287D022-4AB8-4563-B2ED-986503007F94}" type="datetimeFigureOut">
               <a:rPr lang="en-US" smtClean="0"/>
-              <a:t>3/19/2026</a:t>
+              <a:t>6/24/2026</a:t>
             </a:fld>
             <a:endParaRPr lang="en-US"/>
           </a:p>
@@ -1309,7 +1309,7 @@
           <a:p>
             <a:fld id="{6287D022-4AB8-4563-B2ED-986503007F94}" type="datetimeFigureOut">
               <a:rPr lang="en-US" smtClean="0"/>
-              <a:t>3/19/2026</a:t>
+              <a:t>6/24/2026</a:t>
             </a:fld>
             <a:endParaRPr lang="en-US"/>
           </a:p>
@@ -1574,7 +1574,7 @@
           <a:p>
             <a:fld id="{6287D022-4AB8-4563-B2ED-986503007F94}" type="datetimeFigureOut">
               <a:rPr lang="en-US" smtClean="0"/>
-              <a:t>3/19/2026</a:t>
+              <a:t>6/24/2026</a:t>
             </a:fld>
             <a:endParaRPr lang="en-US"/>
           </a:p>
@@ -1986,7 +1986,7 @@
           <a:p>
             <a:fld id="{6287D022-4AB8-4563-B2ED-986503007F94}" type="datetimeFigureOut">
               <a:rPr lang="en-US" smtClean="0"/>
-              <a:t>3/19/2026</a:t>
+              <a:t>6/24/2026</a:t>
             </a:fld>
             <a:endParaRPr lang="en-US"/>
           </a:p>
@@ -2127,7 +2127,7 @@
           <a:p>
             <a:fld id="{6287D022-4AB8-4563-B2ED-986503007F94}" type="datetimeFigureOut">
               <a:rPr lang="en-US" smtClean="0"/>
-              <a:t>3/19/2026</a:t>
+              <a:t>6/24/2026</a:t>
             </a:fld>
             <a:endParaRPr lang="en-US"/>
           </a:p>
@@ -2240,7 +2240,7 @@
           <a:p>
             <a:fld id="{6287D022-4AB8-4563-B2ED-986503007F94}" type="datetimeFigureOut">
               <a:rPr lang="en-US" smtClean="0"/>
-              <a:t>3/19/2026</a:t>
+              <a:t>6/24/2026</a:t>
             </a:fld>
             <a:endParaRPr lang="en-US"/>
           </a:p>
@@ -2551,7 +2551,7 @@
           <a:p>
             <a:fld id="{6287D022-4AB8-4563-B2ED-986503007F94}" type="datetimeFigureOut">
               <a:rPr lang="en-US" smtClean="0"/>
-              <a:t>3/19/2026</a:t>
+              <a:t>6/24/2026</a:t>
             </a:fld>
             <a:endParaRPr lang="en-US"/>
           </a:p>
@@ -2839,7 +2839,7 @@
           <a:p>
             <a:fld id="{6287D022-4AB8-4563-B2ED-986503007F94}" type="datetimeFigureOut">
               <a:rPr lang="en-US" smtClean="0"/>
-              <a:t>3/19/2026</a:t>
+              <a:t>6/24/2026</a:t>
             </a:fld>
             <a:endParaRPr lang="en-US"/>
           </a:p>
@@ -3080,7 +3080,7 @@
           <a:p>
             <a:fld id="{6287D022-4AB8-4563-B2ED-986503007F94}" type="datetimeFigureOut">
               <a:rPr lang="en-US" smtClean="0"/>
-              <a:t>3/19/2026</a:t>
+              <a:t>6/24/2026</a:t>
             </a:fld>
             <a:endParaRPr lang="en-US"/>
           </a:p>
@@ -3973,6 +3973,21 @@
               <a:t>What do you hope to get out of this class?</a:t>
             </a:r>
           </a:p>
+          <a:p>
+            <a:endParaRPr lang="en-US" dirty="0"/>
+          </a:p>
+          <a:p>
+            <a:r>
+              <a:rPr lang="en-US" dirty="0"/>
+              <a:t>Favorite travel experience or travel that you’re looking forward to?</a:t>
+            </a:r>
+          </a:p>
+          <a:p>
+            <a:endParaRPr lang="en-US" dirty="0"/>
+          </a:p>
+          <a:p>
+            <a:endParaRPr lang="en-US" dirty="0"/>
+          </a:p>
         </p:txBody>
       </p:sp>
     </p:spTree>
@@ -4397,4 +4412,10 @@
     </a:ext>
   </a:extLst>
 </a:theme>
+</file>
+
+<file path=docMetadata/LabelInfo.xml><?xml version="1.0" encoding="utf-8"?>
+<clbl:labelList xmlns:clbl="http://schemas.microsoft.com/office/2020/mipLabelMetadata">
+  <clbl:label id="{6dd02d64-b7f3-43f7-a145-cfd68d338edf}" enabled="1" method="Standard" siteId="{0693b5ba-4b18-4d7b-9341-f32f400a5494}" contentBits="0" removed="0"/>
+</clbl:labelList>
 </file>
</xml_diff>

<commit_message>
add ps1 and ps2 completed examples
</commit_message>
<xml_diff>
--- a/Lectures/Day1_0Introductions.pptx
+++ b/Lectures/Day1_0Introductions.pptx
@@ -430,7 +430,7 @@
           <a:p>
             <a:fld id="{6287D022-4AB8-4563-B2ED-986503007F94}" type="datetimeFigureOut">
               <a:rPr lang="en-US" smtClean="0"/>
-              <a:t>6/24/2026</a:t>
+              <a:t>6/25/2026</a:t>
             </a:fld>
             <a:endParaRPr lang="en-US"/>
           </a:p>
@@ -628,7 +628,7 @@
           <a:p>
             <a:fld id="{6287D022-4AB8-4563-B2ED-986503007F94}" type="datetimeFigureOut">
               <a:rPr lang="en-US" smtClean="0"/>
-              <a:t>6/24/2026</a:t>
+              <a:t>6/25/2026</a:t>
             </a:fld>
             <a:endParaRPr lang="en-US"/>
           </a:p>
@@ -836,7 +836,7 @@
           <a:p>
             <a:fld id="{6287D022-4AB8-4563-B2ED-986503007F94}" type="datetimeFigureOut">
               <a:rPr lang="en-US" smtClean="0"/>
-              <a:t>6/24/2026</a:t>
+              <a:t>6/25/2026</a:t>
             </a:fld>
             <a:endParaRPr lang="en-US"/>
           </a:p>
@@ -1034,7 +1034,7 @@
           <a:p>
             <a:fld id="{6287D022-4AB8-4563-B2ED-986503007F94}" type="datetimeFigureOut">
               <a:rPr lang="en-US" smtClean="0"/>
-              <a:t>6/24/2026</a:t>
+              <a:t>6/25/2026</a:t>
             </a:fld>
             <a:endParaRPr lang="en-US"/>
           </a:p>
@@ -1309,7 +1309,7 @@
           <a:p>
             <a:fld id="{6287D022-4AB8-4563-B2ED-986503007F94}" type="datetimeFigureOut">
               <a:rPr lang="en-US" smtClean="0"/>
-              <a:t>6/24/2026</a:t>
+              <a:t>6/25/2026</a:t>
             </a:fld>
             <a:endParaRPr lang="en-US"/>
           </a:p>
@@ -1574,7 +1574,7 @@
           <a:p>
             <a:fld id="{6287D022-4AB8-4563-B2ED-986503007F94}" type="datetimeFigureOut">
               <a:rPr lang="en-US" smtClean="0"/>
-              <a:t>6/24/2026</a:t>
+              <a:t>6/25/2026</a:t>
             </a:fld>
             <a:endParaRPr lang="en-US"/>
           </a:p>
@@ -1986,7 +1986,7 @@
           <a:p>
             <a:fld id="{6287D022-4AB8-4563-B2ED-986503007F94}" type="datetimeFigureOut">
               <a:rPr lang="en-US" smtClean="0"/>
-              <a:t>6/24/2026</a:t>
+              <a:t>6/25/2026</a:t>
             </a:fld>
             <a:endParaRPr lang="en-US"/>
           </a:p>
@@ -2127,7 +2127,7 @@
           <a:p>
             <a:fld id="{6287D022-4AB8-4563-B2ED-986503007F94}" type="datetimeFigureOut">
               <a:rPr lang="en-US" smtClean="0"/>
-              <a:t>6/24/2026</a:t>
+              <a:t>6/25/2026</a:t>
             </a:fld>
             <a:endParaRPr lang="en-US"/>
           </a:p>
@@ -2240,7 +2240,7 @@
           <a:p>
             <a:fld id="{6287D022-4AB8-4563-B2ED-986503007F94}" type="datetimeFigureOut">
               <a:rPr lang="en-US" smtClean="0"/>
-              <a:t>6/24/2026</a:t>
+              <a:t>6/25/2026</a:t>
             </a:fld>
             <a:endParaRPr lang="en-US"/>
           </a:p>
@@ -2551,7 +2551,7 @@
           <a:p>
             <a:fld id="{6287D022-4AB8-4563-B2ED-986503007F94}" type="datetimeFigureOut">
               <a:rPr lang="en-US" smtClean="0"/>
-              <a:t>6/24/2026</a:t>
+              <a:t>6/25/2026</a:t>
             </a:fld>
             <a:endParaRPr lang="en-US"/>
           </a:p>
@@ -2839,7 +2839,7 @@
           <a:p>
             <a:fld id="{6287D022-4AB8-4563-B2ED-986503007F94}" type="datetimeFigureOut">
               <a:rPr lang="en-US" smtClean="0"/>
-              <a:t>6/24/2026</a:t>
+              <a:t>6/25/2026</a:t>
             </a:fld>
             <a:endParaRPr lang="en-US"/>
           </a:p>
@@ -3080,7 +3080,7 @@
           <a:p>
             <a:fld id="{6287D022-4AB8-4563-B2ED-986503007F94}" type="datetimeFigureOut">
               <a:rPr lang="en-US" smtClean="0"/>
-              <a:t>6/24/2026</a:t>
+              <a:t>6/25/2026</a:t>
             </a:fld>
             <a:endParaRPr lang="en-US"/>
           </a:p>
@@ -3825,49 +3825,54 @@
         </p:nvSpPr>
         <p:spPr/>
         <p:txBody>
-          <a:bodyPr/>
-          <a:lstStyle/>
-          <a:p>
-            <a:r>
-              <a:rPr lang="en-US" dirty="0"/>
+          <a:bodyPr>
+            <a:normAutofit/>
+          </a:bodyPr>
+          <a:lstStyle/>
+          <a:p>
+            <a:r>
+              <a:rPr lang="en-US" sz="3200" dirty="0"/>
               <a:t>Facilities</a:t>
             </a:r>
           </a:p>
           <a:p>
             <a:r>
-              <a:rPr lang="en-US" dirty="0"/>
+              <a:rPr lang="en-US" sz="3200" dirty="0"/>
               <a:t>Lunch</a:t>
             </a:r>
           </a:p>
           <a:p>
             <a:r>
-              <a:rPr lang="en-US" dirty="0"/>
-              <a:t>Transportation</a:t>
-            </a:r>
-          </a:p>
-          <a:p>
-            <a:r>
-              <a:rPr lang="en-US" dirty="0"/>
-              <a:t>Class dinner</a:t>
-            </a:r>
-          </a:p>
-          <a:p>
-            <a:r>
-              <a:rPr lang="en-US" dirty="0"/>
+              <a:rPr lang="en-US" sz="3200" dirty="0"/>
               <a:t>Internet</a:t>
             </a:r>
           </a:p>
           <a:p>
-            <a:r>
-              <a:rPr lang="en-US" dirty="0"/>
+            <a:pPr lvl="1"/>
+            <a:r>
+              <a:rPr lang="en-US" sz="3200" dirty="0" err="1"/>
+              <a:t>WCVendor</a:t>
+            </a:r>
+            <a:r>
+              <a:rPr lang="en-US" sz="3200" dirty="0"/>
+              <a:t>; Password: woodardcurran1979</a:t>
+            </a:r>
+          </a:p>
+          <a:p>
+            <a:r>
+              <a:rPr lang="en-US" sz="3200" dirty="0"/>
               <a:t>Software</a:t>
             </a:r>
           </a:p>
           <a:p>
             <a:r>
-              <a:rPr lang="en-US" dirty="0"/>
+              <a:rPr lang="en-US" sz="3200" dirty="0"/>
               <a:t>Agenda</a:t>
             </a:r>
+          </a:p>
+          <a:p>
+            <a:pPr lvl="1"/>
+            <a:endParaRPr lang="en-US" sz="2800" dirty="0"/>
           </a:p>
         </p:txBody>
       </p:sp>

</xml_diff>